<commit_message>
Regenerar materiales y paquetes simplificados
</commit_message>
<xml_diff>
--- a/02-PROFESORADO/03-PRESENTACIONES/POR-SESION/c1/S241-cierre-c1-demo-parcial-y-recuperacion-presentacion.pptx
+++ b/02-PROFESORADO/03-PRESENTACIONES/POR-SESION/c1/S241-cierre-c1-demo-parcial-y-recuperacion-presentacion.pptx
@@ -6081,7 +6081,7 @@
               </a:defRPr>
             </a:pPr>
             <a:r>
-              <a:t>He producido o actualizado: Checklist C1 con aprendizajes pendientes y plan de mejora.</a:t>
+              <a:t>Pueden explicar qué están intentando conseguir.</a:t>
             </a:r>
           </a:p>
         </p:txBody>
@@ -6162,7 +6162,7 @@
               </a:defRPr>
             </a:pPr>
             <a:r>
-              <a:t>Puedo señalar dónde está.</a:t>
+              <a:t>Registran una decisión, prueba o bloqueo; no muestran solo el resultado final.</a:t>
             </a:r>
           </a:p>
         </p:txBody>
@@ -6243,7 +6243,7 @@
               </a:defRPr>
             </a:pPr>
             <a:r>
-              <a:t>Puedo explicar una decisión tomada.</a:t>
+              <a:t>Todas las personas pueden describir su aportación.</a:t>
             </a:r>
           </a:p>
         </p:txBody>
@@ -6324,7 +6324,7 @@
               </a:defRPr>
             </a:pPr>
             <a:r>
-              <a:t>Puedo mostrar una prueba o comprobación.</a:t>
+              <a:t>Comprueban el producto con un criterio observable.</a:t>
             </a:r>
           </a:p>
         </p:txBody>
@@ -6405,7 +6405,7 @@
               </a:defRPr>
             </a:pPr>
             <a:r>
-              <a:t>He registrado mi aportación individual si el trabajo era de equipo.</a:t>
+              <a:t>No usan datos personales, credenciales ni respuestas de ejemplo antes del intento propio.</a:t>
             </a:r>
           </a:p>
         </p:txBody>

</xml_diff>

<commit_message>
Regenerar materiales tras la auditoria de evidencias
</commit_message>
<xml_diff>
--- a/02-PROFESORADO/03-PRESENTACIONES/POR-SESION/c1/S241-cierre-c1-demo-parcial-y-recuperacion-presentacion.pptx
+++ b/02-PROFESORADO/03-PRESENTACIONES/POR-SESION/c1/S241-cierre-c1-demo-parcial-y-recuperacion-presentacion.pptx
@@ -3378,8 +3378,8 @@
         </p:nvSpPr>
         <p:spPr>
           <a:xfrm>
-            <a:off x="713232" y="6272784"/>
-            <a:ext cx="10607040" cy="201168"/>
+            <a:off x="713232" y="4965192"/>
+            <a:ext cx="10241280" cy="594360"/>
           </a:xfrm>
           <a:prstGeom prst="rect">
             <a:avLst/>
@@ -3393,6 +3393,42 @@
           <a:lstStyle/>
           <a:p>
             <a:pPr algn="l">
+              <a:defRPr sz="1700" b="0">
+                <a:solidFill>
+                  <a:srgbClr val="D2D9E4"/>
+                </a:solidFill>
+                <a:latin typeface="Aptos"/>
+              </a:defRPr>
+            </a:pPr>
+            <a:r>
+              <a:t>Equipo → comprobación individual</a:t>
+            </a:r>
+          </a:p>
+        </p:txBody>
+      </p:sp>
+      <p:sp>
+        <p:nvSpPr>
+          <p:cNvPr id="10" name="TextBox 9"/>
+          <p:cNvSpPr txBox="1"/>
+          <p:nvPr/>
+        </p:nvSpPr>
+        <p:spPr>
+          <a:xfrm>
+            <a:off x="713232" y="6272784"/>
+            <a:ext cx="10607040" cy="201168"/>
+          </a:xfrm>
+          <a:prstGeom prst="rect">
+            <a:avLst/>
+          </a:prstGeom>
+          <a:noFill/>
+        </p:spPr>
+        <p:txBody>
+          <a:bodyPr wrap="square" lIns="45720" rIns="45720" tIns="36576" bIns="36576" anchor="t">
+            <a:spAutoFit/>
+          </a:bodyPr>
+          <a:lstStyle/>
+          <a:p>
+            <a:pPr algn="l">
               <a:defRPr sz="1000" b="1">
                 <a:solidFill>
                   <a:srgbClr val="A0AAB9"/>
@@ -3401,7 +3437,7 @@
               </a:defRPr>
             </a:pPr>
             <a:r>
-              <a:t>MINIJARVIS · PROGRAMACIÓN + ENTORNOS DE DESARROLLO</a:t>
+              <a:t>MINIJARVIS · PROGRAMACIÓN</a:t>
             </a:r>
           </a:p>
         </p:txBody>

</xml_diff>